<commit_message>
System Design vi: commit the experiment programs; fix lock remedy and saga wording
- experiments: deterministic programs asserting every number lessons 028 to 032 state
- 031: fencing stays the correctness fix; a longer TTL or renewal only lowers the odds
- 032: only steps before the pivot need compensation; later steps must be retryable

Co-Authored-By: Claude Sonnet 5.5 <noreply@anthropic.com>
Claude-Session: https://claude.ai/code/session_01FUEjJx1iJbs8YafmDVXup4
</commit_message>
<xml_diff>
--- a/system-design-101/vi/lessons/sd-11-031/slides/sd-11-031.pptx
+++ b/system-design-101/vi/lessons/sd-11-031/slides/sd-11-031.pptx
@@ -11969,7 +11969,7 @@
       </p:sp>
       <p:sp>
         <p:nvSpPr>
-          <p:cNvPr id="5" name="Text richtext-1792423168305-397274098"/>
+          <p:cNvPr id="5" name="Text richtext-1792424943888-914158559"/>
           <p:cNvSpPr/>
           <p:nvPr/>
         </p:nvSpPr>
@@ -12079,7 +12079,7 @@
               <a:buChar char="•"/>
             </a:pPr>
             <a:r>
-              <a:rPr lang="en-US" sz="3000" dirty="0" spc="-22" kern="0">
+              <a:rPr lang="en-US" sz="3000" dirty="0" spc="16" kern="0">
                 <a:solidFill>
                   <a:srgbClr val="F3EEE3"/>
                 </a:solidFill>
@@ -12087,7 +12087,51 @@
                 <a:ea typeface="Be Vietnam Pro" pitchFamily="34" charset="-122"/>
                 <a:cs typeface="Be Vietnam Pro" pitchFamily="34" charset="-120"/>
               </a:rPr>
-              <a:t>Đặt</a:t>
+              <a:t>Sửa</a:t>
+            </a:r>
+            <a:r>
+              <a:rPr lang="en-US" sz="3000" dirty="0" spc="-13" kern="0">
+                <a:solidFill>
+                  <a:srgbClr val="F3EEE3"/>
+                </a:solidFill>
+                <a:latin typeface="Be Vietnam Pro" pitchFamily="34" charset="0"/>
+                <a:ea typeface="Be Vietnam Pro" pitchFamily="34" charset="-122"/>
+                <a:cs typeface="Be Vietnam Pro" pitchFamily="34" charset="-120"/>
+              </a:rPr>
+              <a:t> gốc:</a:t>
+            </a:r>
+            <a:r>
+              <a:rPr lang="en-US" sz="3000" dirty="0" spc="3" kern="0">
+                <a:solidFill>
+                  <a:srgbClr val="F3EEE3"/>
+                </a:solidFill>
+                <a:latin typeface="Be Vietnam Pro" pitchFamily="34" charset="0"/>
+                <a:ea typeface="Be Vietnam Pro" pitchFamily="34" charset="-122"/>
+                <a:cs typeface="Be Vietnam Pro" pitchFamily="34" charset="-120"/>
+              </a:rPr>
+              <a:t> ghi</a:t>
+            </a:r>
+            <a:r>
+              <a:rPr lang="en-US" sz="3000" dirty="0" spc="1" kern="0">
+                <a:solidFill>
+                  <a:srgbClr val="F3EEE3"/>
+                </a:solidFill>
+                <a:latin typeface="Be Vietnam Pro" pitchFamily="34" charset="0"/>
+                <a:ea typeface="Be Vietnam Pro" pitchFamily="34" charset="-122"/>
+                <a:cs typeface="Be Vietnam Pro" pitchFamily="34" charset="-120"/>
+              </a:rPr>
+              <a:t> lặp</a:t>
+            </a:r>
+            <a:r>
+              <a:rPr lang="en-US" sz="3000" dirty="0" spc="-16" kern="0">
+                <a:solidFill>
+                  <a:srgbClr val="F3EEE3"/>
+                </a:solidFill>
+                <a:latin typeface="Be Vietnam Pro" pitchFamily="34" charset="0"/>
+                <a:ea typeface="Be Vietnam Pro" pitchFamily="34" charset="-122"/>
+                <a:cs typeface="Be Vietnam Pro" pitchFamily="34" charset="-120"/>
+              </a:rPr>
+              <a:t> vô</a:t>
             </a:r>
             <a:r>
               <a:rPr lang="en-US" sz="3000" dirty="0" spc="0" kern="0">
@@ -12098,10 +12142,10 @@
                 <a:ea typeface="Be Vietnam Pro" pitchFamily="34" charset="-122"/>
                 <a:cs typeface="Be Vietnam Pro" pitchFamily="34" charset="-120"/>
               </a:rPr>
-              <a:t> TTL</a:t>
-            </a:r>
-            <a:r>
-              <a:rPr lang="en-US" sz="3000" dirty="0" spc="2" kern="0">
+              <a:t> hại,</a:t>
+            </a:r>
+            <a:r>
+              <a:rPr lang="en-US" sz="3000" dirty="0" spc="-3" kern="0">
                 <a:solidFill>
                   <a:srgbClr val="F3EEE3"/>
                 </a:solidFill>
@@ -12109,10 +12153,10 @@
                 <a:ea typeface="Be Vietnam Pro" pitchFamily="34" charset="-122"/>
                 <a:cs typeface="Be Vietnam Pro" pitchFamily="34" charset="-120"/>
               </a:rPr>
-              <a:t> dài</a:t>
-            </a:r>
-            <a:r>
-              <a:rPr lang="en-US" sz="3000" dirty="0" spc="-1" kern="0">
+              <a:t> hoặc</a:t>
+            </a:r>
+            <a:r>
+              <a:rPr lang="en-US" sz="3000" dirty="0" spc="-11" kern="0">
                 <a:solidFill>
                   <a:srgbClr val="F3EEE3"/>
                 </a:solidFill>
@@ -12120,62 +12164,7 @@
                 <a:ea typeface="Be Vietnam Pro" pitchFamily="34" charset="-122"/>
                 <a:cs typeface="Be Vietnam Pro" pitchFamily="34" charset="-120"/>
               </a:rPr>
-              <a:t> hơn</a:t>
-            </a:r>
-            <a:r>
-              <a:rPr lang="en-US" sz="3000" dirty="0" spc="2" kern="0">
-                <a:solidFill>
-                  <a:srgbClr val="F3EEE3"/>
-                </a:solidFill>
-                <a:latin typeface="Be Vietnam Pro" pitchFamily="34" charset="0"/>
-                <a:ea typeface="Be Vietnam Pro" pitchFamily="34" charset="-122"/>
-                <a:cs typeface="Be Vietnam Pro" pitchFamily="34" charset="-120"/>
-              </a:rPr>
-              <a:t> thời</a:t>
-            </a:r>
-            <a:r>
-              <a:rPr lang="en-US" sz="3000" dirty="0" spc="1" kern="0">
-                <a:solidFill>
-                  <a:srgbClr val="F3EEE3"/>
-                </a:solidFill>
-                <a:latin typeface="Be Vietnam Pro" pitchFamily="34" charset="0"/>
-                <a:ea typeface="Be Vietnam Pro" pitchFamily="34" charset="-122"/>
-                <a:cs typeface="Be Vietnam Pro" pitchFamily="34" charset="-120"/>
-              </a:rPr>
-              <a:t> gian</a:t>
-            </a:r>
-            <a:r>
-              <a:rPr lang="en-US" sz="3000" dirty="0" spc="-9" kern="0">
-                <a:solidFill>
-                  <a:srgbClr val="F3EEE3"/>
-                </a:solidFill>
-                <a:latin typeface="Be Vietnam Pro" pitchFamily="34" charset="0"/>
-                <a:ea typeface="Be Vietnam Pro" pitchFamily="34" charset="-122"/>
-                <a:cs typeface="Be Vietnam Pro" pitchFamily="34" charset="-120"/>
-              </a:rPr>
-              <a:t> chạy</a:t>
-            </a:r>
-            <a:r>
-              <a:rPr lang="en-US" sz="3000" dirty="0" spc="-23" kern="0">
-                <a:solidFill>
-                  <a:srgbClr val="F3EEE3"/>
-                </a:solidFill>
-                <a:latin typeface="Be Vietnam Pro" pitchFamily="34" charset="0"/>
-                <a:ea typeface="Be Vietnam Pro" pitchFamily="34" charset="-122"/>
-                <a:cs typeface="Be Vietnam Pro" pitchFamily="34" charset="-120"/>
-              </a:rPr>
-              <a:t> xấu</a:t>
-            </a:r>
-            <a:r>
-              <a:rPr lang="en-US" sz="3000" dirty="0" spc="-13" kern="0">
-                <a:solidFill>
-                  <a:srgbClr val="F3EEE3"/>
-                </a:solidFill>
-                <a:latin typeface="Be Vietnam Pro" pitchFamily="34" charset="0"/>
-                <a:ea typeface="Be Vietnam Pro" pitchFamily="34" charset="-122"/>
-                <a:cs typeface="Be Vietnam Pro" pitchFamily="34" charset="-120"/>
-              </a:rPr>
-              <a:t> nhất.</a:t>
+              <a:t> fencing.</a:t>
             </a:r>
             <a:endParaRPr lang="en-US" sz="3000" dirty="0"/>
           </a:p>
@@ -12186,7 +12175,7 @@
               <a:buChar char="•"/>
             </a:pPr>
             <a:r>
-              <a:rPr lang="en-US" sz="3000" dirty="0" spc="-4" kern="0">
+              <a:rPr lang="en-US" sz="3000" dirty="0" spc="-1" kern="0">
                 <a:solidFill>
                   <a:srgbClr val="F3EEE3"/>
                 </a:solidFill>
@@ -12194,7 +12183,29 @@
                 <a:ea typeface="Be Vietnam Pro" pitchFamily="34" charset="-122"/>
                 <a:cs typeface="Be Vietnam Pro" pitchFamily="34" charset="-120"/>
               </a:rPr>
-              <a:t>Hoặc</a:t>
+              <a:t>TTL</a:t>
+            </a:r>
+            <a:r>
+              <a:rPr lang="en-US" sz="3000" dirty="0" spc="2" kern="0">
+                <a:solidFill>
+                  <a:srgbClr val="F3EEE3"/>
+                </a:solidFill>
+                <a:latin typeface="Be Vietnam Pro" pitchFamily="34" charset="0"/>
+                <a:ea typeface="Be Vietnam Pro" pitchFamily="34" charset="-122"/>
+                <a:cs typeface="Be Vietnam Pro" pitchFamily="34" charset="-120"/>
+              </a:rPr>
+              <a:t> dài</a:t>
+            </a:r>
+            <a:r>
+              <a:rPr lang="en-US" sz="3000" dirty="0" spc="-1" kern="0">
+                <a:solidFill>
+                  <a:srgbClr val="F3EEE3"/>
+                </a:solidFill>
+                <a:latin typeface="Be Vietnam Pro" pitchFamily="34" charset="0"/>
+                <a:ea typeface="Be Vietnam Pro" pitchFamily="34" charset="-122"/>
+                <a:cs typeface="Be Vietnam Pro" pitchFamily="34" charset="-120"/>
+              </a:rPr>
+              <a:t> hơn,</a:t>
             </a:r>
             <a:r>
               <a:rPr lang="en-US" sz="3000" dirty="0" spc="3" kern="0">
@@ -12208,6 +12219,39 @@
               <a:t> gia</a:t>
             </a:r>
             <a:r>
+              <a:rPr lang="en-US" sz="3000" dirty="0" spc="-3" kern="0">
+                <a:solidFill>
+                  <a:srgbClr val="F3EEE3"/>
+                </a:solidFill>
+                <a:latin typeface="Be Vietnam Pro" pitchFamily="34" charset="0"/>
+                <a:ea typeface="Be Vietnam Pro" pitchFamily="34" charset="-122"/>
+                <a:cs typeface="Be Vietnam Pro" pitchFamily="34" charset="-120"/>
+              </a:rPr>
+              <a:t> hạn:</a:t>
+            </a:r>
+            <a:r>
+              <a:rPr lang="en-US" sz="3000" dirty="0" spc="2" kern="0">
+                <a:solidFill>
+                  <a:srgbClr val="F3EEE3"/>
+                </a:solidFill>
+                <a:latin typeface="Be Vietnam Pro" pitchFamily="34" charset="0"/>
+                <a:ea typeface="Be Vietnam Pro" pitchFamily="34" charset="-122"/>
+                <a:cs typeface="Be Vietnam Pro" pitchFamily="34" charset="-120"/>
+              </a:rPr>
+              <a:t> chỉ giảm</a:t>
+            </a:r>
+            <a:r>
+              <a:rPr lang="en-US" sz="3000" dirty="0" spc="0" kern="0">
+                <a:solidFill>
+                  <a:srgbClr val="F3EEE3"/>
+                </a:solidFill>
+                <a:latin typeface="Be Vietnam Pro" pitchFamily="34" charset="0"/>
+                <a:ea typeface="Be Vietnam Pro" pitchFamily="34" charset="-122"/>
+                <a:cs typeface="Be Vietnam Pro" pitchFamily="34" charset="-120"/>
+              </a:rPr>
+              <a:t> khả</a:t>
+            </a:r>
+            <a:r>
               <a:rPr lang="en-US" sz="3000" dirty="0" spc="-2" kern="0">
                 <a:solidFill>
                   <a:srgbClr val="F3EEE3"/>
@@ -12216,40 +12260,7 @@
                 <a:ea typeface="Be Vietnam Pro" pitchFamily="34" charset="-122"/>
                 <a:cs typeface="Be Vietnam Pro" pitchFamily="34" charset="-120"/>
               </a:rPr>
-              <a:t> hạn</a:t>
-            </a:r>
-            <a:r>
-              <a:rPr lang="en-US" sz="3000" dirty="0" spc="0" kern="0">
-                <a:solidFill>
-                  <a:srgbClr val="F3EEE3"/>
-                </a:solidFill>
-                <a:latin typeface="Be Vietnam Pro" pitchFamily="34" charset="0"/>
-                <a:ea typeface="Be Vietnam Pro" pitchFamily="34" charset="-122"/>
-                <a:cs typeface="Be Vietnam Pro" pitchFamily="34" charset="-120"/>
-              </a:rPr>
-              <a:t> khóa</a:t>
-            </a:r>
-            <a:r>
-              <a:rPr lang="en-US" sz="3000" dirty="0" spc="23" kern="0">
-                <a:solidFill>
-                  <a:srgbClr val="F3EEE3"/>
-                </a:solidFill>
-                <a:latin typeface="Be Vietnam Pro" pitchFamily="34" charset="0"/>
-                <a:ea typeface="Be Vietnam Pro" pitchFamily="34" charset="-122"/>
-                <a:cs typeface="Be Vietnam Pro" pitchFamily="34" charset="-120"/>
-              </a:rPr>
-              <a:t> định</a:t>
-            </a:r>
-            <a:r>
-              <a:rPr lang="en-US" sz="3000" dirty="0" spc="0" kern="0">
-                <a:solidFill>
-                  <a:srgbClr val="F3EEE3"/>
-                </a:solidFill>
-                <a:latin typeface="Be Vietnam Pro" pitchFamily="34" charset="0"/>
-                <a:ea typeface="Be Vietnam Pro" pitchFamily="34" charset="-122"/>
-                <a:cs typeface="Be Vietnam Pro" pitchFamily="34" charset="-120"/>
-              </a:rPr>
-              <a:t> kỳ.</a:t>
+              <a:t> năng.</a:t>
             </a:r>
             <a:endParaRPr lang="en-US" sz="3000" dirty="0"/>
           </a:p>

</xml_diff>